<commit_message>
PlayBooks: shareable wording; sizing in R, no account rules or private tooling
Removes the personal R units, account and window names, private tool paths and dated incidents
from both decks; byline Trading As Buddies with the public repo; SMB credited as the format.
The FL gate correction moves from the title slide to a one-line lesson in Trade Review.

Co-Authored-By: Claude Fable 5.1 <noreply@anthropic.com>
</commit_message>
<xml_diff>
--- a/docs/playbook/PlayBook-34SMA-Premarket-Trend.pptx
+++ b/docs/playbook/PlayBook-34SMA-Premarket-Trend.pptx
@@ -3173,7 +3173,7 @@
                 </a:solidFill>
                 <a:latin typeface="Lato"/>
               </a:rPr>
-              <a:t>SMB PlayBook · davdunc · example trade RKLB · May 11, 2026</a:t>
+              <a:t>A Trading As Buddies PlayBook · example trade RKLB · May 11, 2026</a:t>
             </a:r>
           </a:p>
         </p:txBody>
@@ -3212,7 +3212,7 @@
                 </a:solidFill>
                 <a:latin typeface="Lato"/>
               </a:rPr>
-              <a:t>Hypothetical backtest results on Massive.com minute data; simulated trades were not executed and do not reflect slippage, commissions or liquidity except where stated. Not investment advice. PlayBook format after SMB Training.</a:t>
+              <a:t>Hypothetical backtest results on Massive.com minute data; simulated trades were not executed and do not reflect slippage, commissions or liquidity except where stated. Not investment advice. Trading As Buddies · github.com/TradingAsBuddies/DAS-hotkeys · PlayBook format after SMB Training (not affiliated).</a:t>
             </a:r>
           </a:p>
         </p:txBody>
@@ -3415,7 +3415,7 @@
                 </a:solidFill>
                 <a:latin typeface="Lato"/>
               </a:rPr>
-              <a:t>•  Status</a:t>
+              <a:t>•  How to start</a:t>
             </a:r>
             <a:r>
               <a:rPr sz="1600">
@@ -3424,7 +3424,7 @@
                 </a:solidFill>
                 <a:latin typeface="Lato"/>
               </a:rPr>
-              <a:t> 1R paper experiment. Every element of this rule was chosen after seeing the data; treat the numbers as in-sample.</a:t>
+              <a:t> trade it at 1R in simulation until you have twenty stop fills to measure. Every element of this rule was chosen after seeing the data; treat the numbers as in-sample.</a:t>
             </a:r>
           </a:p>
         </p:txBody>
@@ -3559,7 +3559,7 @@
                 </a:solidFill>
                 <a:latin typeface="Lato"/>
               </a:rPr>
-              <a:t>Hypothetical backtest results on Massive.com minute data; simulated trades were not executed and do not reflect slippage, commissions or liquidity except where stated. Not investment advice. PlayBook format after SMB Training.</a:t>
+              <a:t>Hypothetical backtest results on Massive.com minute data; simulated trades were not executed and do not reflect slippage, commissions or liquidity except where stated. Not investment advice. Trading As Buddies · github.com/TradingAsBuddies/DAS-hotkeys · PlayBook format after SMB Training (not affiliated).</a:t>
             </a:r>
           </a:p>
         </p:txBody>
@@ -3637,7 +3637,7 @@
                 </a:solidFill>
                 <a:latin typeface="Lato"/>
               </a:rPr>
-              <a:t>•  Scan</a:t>
+              <a:t>•  Scan (09:15)</a:t>
             </a:r>
             <a:r>
               <a:rPr sz="1300">
@@ -3646,7 +3646,7 @@
                 </a:solidFill>
                 <a:latin typeface="Lato"/>
               </a:rPr>
-              <a:t> fl_forward_test.py breadth and gameplan reader; premarket-ratio filter is the --pm-vol-mult logic in backtest_sma34_trend.py, to be lifted into the driver.</a:t>
+              <a:t> any scanner that shows premarket volume against the name's own average; the rule is today's premarket volume ÷ the 20-day median premarket volume ≥ 2.</a:t>
             </a:r>
           </a:p>
           <a:p>
@@ -3662,7 +3662,7 @@
                 </a:solidFill>
                 <a:latin typeface="Lato"/>
               </a:rPr>
-              <a:t>•  Order</a:t>
+              <a:t>•  Chart</a:t>
             </a:r>
             <a:r>
               <a:rPr sz="1300">
@@ -3671,7 +3671,7 @@
                 </a:solidFill>
                 <a:latin typeface="Lato"/>
               </a:rPr>
-              <a:t> DAS bracket via the CMD API (SCRIPT montage1 …): limit at the level, SLP stop at 1.0×ATR, sized by the R-CONFIG unit. Refuses without an ATR value.</a:t>
+              <a:t> 15-minute with extended hours ON, studies 9-EMA, 34-SMA and VWAP reset at 04:00 (premarket). A regular-hours chart gives a different level and a worse result for this form.</a:t>
             </a:r>
           </a:p>
           <a:p>
@@ -3687,7 +3687,7 @@
                 </a:solidFill>
                 <a:latin typeface="Lato"/>
               </a:rPr>
-              <a:t>•  Exit</a:t>
+              <a:t>•  Order</a:t>
             </a:r>
             <a:r>
               <a:rPr sz="1300">
@@ -3696,7 +3696,7 @@
                 </a:solidFill>
                 <a:latin typeface="Lato"/>
               </a:rPr>
-              <a:t> 9-EMA close monitor on 15-minute bars, same pattern as the FL driver's ema9 exit; breakeven and flatten paths already exist (22-fl-flatten.das).</a:t>
+              <a:t> a bracket placed before 09:30: limit at the 34-SMA value, stop 1.0×ATR away, quantity = 1R ÷ stop distance. In DAS Trader Pro that is one hotkey script; the open-source version is in the repo (scripts/).</a:t>
             </a:r>
           </a:p>
           <a:p>
@@ -3712,7 +3712,7 @@
                 </a:solidFill>
                 <a:latin typeface="Lato"/>
               </a:rPr>
-              <a:t>•  Chart</a:t>
+              <a:t>•  Exit</a:t>
             </a:r>
             <a:r>
               <a:rPr sz="1300">
@@ -3721,7 +3721,7 @@
                 </a:solidFill>
                 <a:latin typeface="Lato"/>
               </a:rPr>
-              <a:t> DAS 15-minute with extended hours ON, studies 9-EMA, 34-SMA, VWAP (premarket); the regular-hours chart gives a different level and a worse result for this form.</a:t>
+              <a:t> watch the 15-minute closes against the 9-EMA; the exit is a market order at the open of the bar after the first close back across it. This can be a chart alert or a script.</a:t>
             </a:r>
           </a:p>
           <a:p>
@@ -3737,7 +3737,7 @@
                 </a:solidFill>
                 <a:latin typeface="Lato"/>
               </a:rPr>
-              <a:t>•  Safety</a:t>
+              <a:t>•  Backtest</a:t>
             </a:r>
             <a:r>
               <a:rPr sz="1300">
@@ -3746,7 +3746,7 @@
                 </a:solidFill>
                 <a:latin typeface="Lato"/>
               </a:rPr>
-              <a:t> paper account TR4425 only until twenty live stop fills are measured; the driver halts new entries when the montage name is lost (the 09-25 failure).</a:t>
+              <a:t> backtest/backtest_sma34_trend.py in the repo reproduces every number in this deck from Massive.com (Polygon) flat files; report in docs/forward-tests/sma34-trend-3y.md.</a:t>
             </a:r>
           </a:p>
           <a:p>
@@ -3762,7 +3762,7 @@
                 </a:solidFill>
                 <a:latin typeface="Lato"/>
               </a:rPr>
-              <a:t>•  Reproduce</a:t>
+              <a:t>•  Safety</a:t>
             </a:r>
             <a:r>
               <a:rPr sz="1300">
@@ -3771,7 +3771,7 @@
                 </a:solidFill>
                 <a:latin typeface="Lato"/>
               </a:rPr>
-              <a:t> docs/forward-tests/sma34-trend-3y.md, backtest/results/sma34-3y-preopen-ext-ema-s10.json.</a:t>
+              <a:t> simulation first, one R, until you have measured twenty of your own stop fills against the stop price.</a:t>
             </a:r>
           </a:p>
         </p:txBody>
@@ -3906,7 +3906,7 @@
                 </a:solidFill>
                 <a:latin typeface="Lato"/>
               </a:rPr>
-              <a:t>Hypothetical backtest results on Massive.com minute data; simulated trades were not executed and do not reflect slippage, commissions or liquidity except where stated. Not investment advice. PlayBook format after SMB Training.</a:t>
+              <a:t>Hypothetical backtest results on Massive.com minute data; simulated trades were not executed and do not reflect slippage, commissions or liquidity except where stated. Not investment advice. Trading As Buddies · github.com/TradingAsBuddies/DAS-hotkeys · PlayBook format after SMB Training (not affiliated).</a:t>
             </a:r>
           </a:p>
         </p:txBody>
@@ -4118,7 +4118,7 @@
                 </a:solidFill>
                 <a:latin typeface="Lato"/>
               </a:rPr>
-              <a:t> measure live stop slippage on TR4425; add --entry-window and the premarket scan to the driver; write the DAS bracket hotkey for the pre-open order.</a:t>
+              <a:t> measure your live stop slippage in simulation; test an entry window; run a walk-forward on the premarket band before sizing above 1R.</a:t>
             </a:r>
           </a:p>
         </p:txBody>
@@ -4277,7 +4277,7 @@
                 </a:solidFill>
                 <a:latin typeface="Lato"/>
               </a:rPr>
-              <a:t>Hypothetical backtest results on Massive.com minute data; simulated trades were not executed and do not reflect slippage, commissions or liquidity except where stated. Not investment advice. PlayBook format after SMB Training.</a:t>
+              <a:t>Hypothetical backtest results on Massive.com minute data; simulated trades were not executed and do not reflect slippage, commissions or liquidity except where stated. Not investment advice. Trading As Buddies · github.com/TradingAsBuddies/DAS-hotkeys · PlayBook format after SMB Training (not affiliated).</a:t>
             </a:r>
           </a:p>
         </p:txBody>
@@ -4537,7 +4537,7 @@
                           </a:solidFill>
                           <a:latin typeface="Lato"/>
                         </a:rPr>
-                        <a:t>1R = the planned stop distance × shares = $75 in SIM</a:t>
+                        <a:t>1R = your risk per trade = planned stop distance × shares</a:t>
                       </a:r>
                     </a:p>
                   </a:txBody>
@@ -4993,7 +4993,7 @@
                 </a:solidFill>
                 <a:latin typeface="Lato"/>
               </a:rPr>
-              <a:t>Hypothetical backtest results on Massive.com minute data; simulated trades were not executed and do not reflect slippage, commissions or liquidity except where stated. Not investment advice. PlayBook format after SMB Training.</a:t>
+              <a:t>Hypothetical backtest results on Massive.com minute data; simulated trades were not executed and do not reflect slippage, commissions or liquidity except where stated. Not investment advice. Trading As Buddies · github.com/TradingAsBuddies/DAS-hotkeys · PlayBook format after SMB Training (not affiliated).</a:t>
             </a:r>
           </a:p>
         </p:txBody>
@@ -5639,7 +5639,7 @@
                           </a:solidFill>
                           <a:latin typeface="Lato"/>
                         </a:rPr>
-                        <a:t>8</a:t>
+                        <a:t>7</a:t>
                       </a:r>
                     </a:p>
                   </a:txBody>
@@ -5661,7 +5661,7 @@
                           </a:solidFill>
                           <a:latin typeface="Lato"/>
                         </a:rPr>
-                        <a:t>Backtester, driver, CMD API harness and flatten paths exist; pre-open bracket hotkey still to write.</a:t>
+                        <a:t>Backtester and DAS scripts are open source; the pre-open bracket is one hotkey; the 9-EMA exit still needs an alert or script.</a:t>
                       </a:r>
                     </a:p>
                   </a:txBody>
@@ -5874,7 +5874,7 @@
                 </a:solidFill>
                 <a:latin typeface="Lato"/>
               </a:rPr>
-              <a:t>Hypothetical backtest results on Massive.com minute data; simulated trades were not executed and do not reflect slippage, commissions or liquidity except where stated. Not investment advice. PlayBook format after SMB Training.</a:t>
+              <a:t>Hypothetical backtest results on Massive.com minute data; simulated trades were not executed and do not reflect slippage, commissions or liquidity except where stated. Not investment advice. Trading As Buddies · github.com/TradingAsBuddies/DAS-hotkeys · PlayBook format after SMB Training (not affiliated).</a:t>
             </a:r>
           </a:p>
         </p:txBody>
@@ -6111,7 +6111,7 @@
                 </a:solidFill>
                 <a:latin typeface="Lato"/>
               </a:rPr>
-              <a:t>Hypothetical backtest results on Massive.com minute data; simulated trades were not executed and do not reflect slippage, commissions or liquidity except where stated. Not investment advice. PlayBook format after SMB Training.</a:t>
+              <a:t>Hypothetical backtest results on Massive.com minute data; simulated trades were not executed and do not reflect slippage, commissions or liquidity except where stated. Not investment advice. Trading As Buddies · github.com/TradingAsBuddies/DAS-hotkeys · PlayBook format after SMB Training (not affiliated).</a:t>
             </a:r>
           </a:p>
         </p:txBody>
@@ -6348,7 +6348,7 @@
                 </a:solidFill>
                 <a:latin typeface="Lato"/>
               </a:rPr>
-              <a:t>Hypothetical backtest results on Massive.com minute data; simulated trades were not executed and do not reflect slippage, commissions or liquidity except where stated. Not investment advice. PlayBook format after SMB Training.</a:t>
+              <a:t>Hypothetical backtest results on Massive.com minute data; simulated trades were not executed and do not reflect slippage, commissions or liquidity except where stated. Not investment advice. Trading As Buddies · github.com/TradingAsBuddies/DAS-hotkeys · PlayBook format after SMB Training (not affiliated).</a:t>
             </a:r>
           </a:p>
         </p:txBody>
@@ -6510,7 +6510,7 @@
                 </a:solidFill>
                 <a:latin typeface="Lato"/>
               </a:rPr>
-              <a:t> AMD BB CRWD DELL DRI INTC IONQ META MSTR NVDA RKLB SMCI TSLA XOM. No ETFs, commodities or small caps: the tight stop needs single-stock range and the premarket-volume filter needs a name with a normal premarket.</a:t>
+              <a:t> your in-play list of medium and large caps (tested on AMD BB CRWD DELL DRI INTC IONQ META MSTR NVDA RKLB SMCI TSLA XOM). No ETFs, commodities or small caps: the stop needs single-stock range and the premarket filter needs a name with a normal premarket.</a:t>
             </a:r>
           </a:p>
         </p:txBody>
@@ -7303,7 +7303,7 @@
                 </a:solidFill>
                 <a:latin typeface="Lato"/>
               </a:rPr>
-              <a:t>Hypothetical backtest results on Massive.com minute data; simulated trades were not executed and do not reflect slippage, commissions or liquidity except where stated. Not investment advice. PlayBook format after SMB Training.</a:t>
+              <a:t>Hypothetical backtest results on Massive.com minute data; simulated trades were not executed and do not reflect slippage, commissions or liquidity except where stated. Not investment advice. Trading As Buddies · github.com/TradingAsBuddies/DAS-hotkeys · PlayBook format after SMB Training (not affiliated).</a:t>
             </a:r>
           </a:p>
         </p:txBody>
@@ -7501,7 +7501,7 @@
                 </a:solidFill>
                 <a:latin typeface="Lato"/>
               </a:rPr>
-              <a:t>Hypothetical backtest results on Massive.com minute data; simulated trades were not executed and do not reflect slippage, commissions or liquidity except where stated. Not investment advice. PlayBook format after SMB Training.</a:t>
+              <a:t>Hypothetical backtest results on Massive.com minute data; simulated trades were not executed and do not reflect slippage, commissions or liquidity except where stated. Not investment advice. Trading As Buddies · github.com/TradingAsBuddies/DAS-hotkeys · PlayBook format after SMB Training (not affiliated).</a:t>
             </a:r>
           </a:p>
         </p:txBody>
@@ -7738,7 +7738,7 @@
                 </a:solidFill>
                 <a:latin typeface="Lato"/>
               </a:rPr>
-              <a:t>Hypothetical backtest results on Massive.com minute data; simulated trades were not executed and do not reflect slippage, commissions or liquidity except where stated. Not investment advice. PlayBook format after SMB Training.</a:t>
+              <a:t>Hypothetical backtest results on Massive.com minute data; simulated trades were not executed and do not reflect slippage, commissions or liquidity except where stated. Not investment advice. Trading As Buddies · github.com/TradingAsBuddies/DAS-hotkeys · PlayBook format after SMB Training (not affiliated).</a:t>
             </a:r>
           </a:p>
         </p:txBody>
@@ -7950,7 +7950,7 @@
                 </a:solidFill>
                 <a:latin typeface="Lato"/>
               </a:rPr>
-              <a:t> order live 09:30 to 15:00; anything still open is flat at 15:55. One entry per name per day; one position per day if that is the account rule.</a:t>
+              <a:t> order live 09:30 to 15:00; anything still open is flat at 15:55. One entry per name per day. Simplest form: one position a day, in the name with the heaviest premarket (+32R on 230 trades).</a:t>
             </a:r>
           </a:p>
           <a:p>
@@ -7975,7 +7975,7 @@
                 </a:solidFill>
                 <a:latin typeface="Lato"/>
               </a:rPr>
-              <a:t> shares = 1R ÷ stop distance, 1R = $75 in SIM (TR4425), $28 live, per PREFERENCES.md R-CONFIG. Cap 300 shares.</a:t>
+              <a:t> shares = 1R ÷ stop distance, where 1R is the amount you risk per trade (we test at a tenth of a percent of capital). Cap size to what the name's liquidity fills cleanly.</a:t>
             </a:r>
           </a:p>
           <a:p>
@@ -8135,7 +8135,7 @@
                 </a:solidFill>
                 <a:latin typeface="Lato"/>
               </a:rPr>
-              <a:t>Hypothetical backtest results on Massive.com minute data; simulated trades were not executed and do not reflect slippage, commissions or liquidity except where stated. Not investment advice. PlayBook format after SMB Training.</a:t>
+              <a:t>Hypothetical backtest results on Massive.com minute data; simulated trades were not executed and do not reflect slippage, commissions or liquidity except where stated. Not investment advice. Trading As Buddies · github.com/TradingAsBuddies/DAS-hotkeys · PlayBook format after SMB Training (not affiliated).</a:t>
             </a:r>
           </a:p>
         </p:txBody>
@@ -8462,7 +8462,7 @@
                           </a:solidFill>
                           <a:latin typeface="Lato"/>
                         </a:rPr>
-                        <a:t>stop 103.04 (1.0×ATR); 54 shares = $75 ÷ 1.37</a:t>
+                        <a:t>stop 103.04 (1.0×ATR); shares = 1R ÷ 1.37</a:t>
                       </a:r>
                     </a:p>
                   </a:txBody>
@@ -9120,7 +9120,7 @@
                 </a:solidFill>
                 <a:latin typeface="Lato"/>
               </a:rPr>
-              <a:t>Hypothetical backtest results on Massive.com minute data; simulated trades were not executed and do not reflect slippage, commissions or liquidity except where stated. Not investment advice. PlayBook format after SMB Training.</a:t>
+              <a:t>Hypothetical backtest results on Massive.com minute data; simulated trades were not executed and do not reflect slippage, commissions or liquidity except where stated. Not investment advice. Trading As Buddies · github.com/TradingAsBuddies/DAS-hotkeys · PlayBook format after SMB Training (not affiliated).</a:t>
             </a:r>
           </a:p>
         </p:txBody>

</xml_diff>

<commit_message>
Catalyst attribution from SEC EDGAR; catalyst rule in both PlayBooks
backtest/catalysts/catalysts.py joins EDGAR submissions (8-K item 2.02 = earnings, reaction
session by acceptance time; other 8-K, offerings, 10-Q/K) to every backtest trade day.
34-SMA: earnings/8-K mornings 106 trades -27R (p=0.017); excluded, 627 trades +114R, DD 26.7R,
+69R with 5c slip. FL: catalyst mornings 204 trades +59R at +0.29R/trade (p=0.004) and +48R of
the +65R that survives 5c slip. Decks gain a catalyst slide and rule; report added.

Co-Authored-By: Claude Fable 5.1 <noreply@anthropic.com>
</commit_message>
<xml_diff>
--- a/docs/playbook/PlayBook-34SMA-Premarket-Trend.pptx
+++ b/docs/playbook/PlayBook-34SMA-Premarket-Trend.pptx
@@ -18,6 +18,7 @@
     <p:sldId id="266" r:id="rId17"/>
     <p:sldId id="267" r:id="rId18"/>
     <p:sldId id="268" r:id="rId19"/>
+    <p:sldId id="269" r:id="rId20"/>
   </p:sldIdLst>
   <p:sldSz cx="12191695" cy="6858000" type="screen4x3"/>
   <p:notesSz cx="6858000" cy="9144000"/>
@@ -3349,7 +3350,7 @@
                 </a:solidFill>
                 <a:latin typeface="Lato"/>
               </a:rPr>
-              <a:t> medium and large caps with premarket volume at least 2× their own 20-day median.</a:t>
+              <a:t> medium and large caps with premarket volume at least 2× their own 20-day median, and no earnings release or 8-K in the prior 24 hours.</a:t>
             </a:r>
           </a:p>
           <a:p>
@@ -3399,7 +3400,7 @@
                 </a:solidFill>
                 <a:latin typeface="Lato"/>
               </a:rPr>
-              <a:t> 733 simulated trades over three years on 14 names, +86R, +35R after 5¢ of stop slippage.</a:t>
+              <a:t> 733 simulated trades over three years on 14 names, +86R; without earnings and 8-K days 627 trades, +114R, +69R after 5¢ of stop slippage.</a:t>
             </a:r>
           </a:p>
           <a:p>
@@ -3481,7 +3482,7 @@
                 </a:solidFill>
                 <a:latin typeface="Lato"/>
               </a:rPr>
-              <a:t>TECHNOLOGY</a:t>
+              <a:t>READING THE TAPE</a:t>
             </a:r>
           </a:p>
         </p:txBody>
@@ -3520,7 +3521,7 @@
                 </a:solidFill>
                 <a:latin typeface="Lato"/>
               </a:rPr>
-              <a:t>Everything the trade needs is scripted; the human job is the 09:15 read and the order</a:t>
+              <a:t>What to watch at the level between 09:30 and 10:00</a:t>
             </a:r>
           </a:p>
         </p:txBody>
@@ -3637,7 +3638,7 @@
                 </a:solidFill>
                 <a:latin typeface="Lato"/>
               </a:rPr>
-              <a:t>•  Scan (09:15)</a:t>
+              <a:t>•  At the 34-SMA</a:t>
             </a:r>
             <a:r>
               <a:rPr sz="1300">
@@ -3646,7 +3647,7 @@
                 </a:solidFill>
                 <a:latin typeface="Lato"/>
               </a:rPr>
-              <a:t> any scanner that shows premarket volume against the name's own average; the rule is today's premarket volume ÷ the 20-day median premarket volume ≥ 2.</a:t>
+              <a:t> does the opening drive stall at the level or trade through it? A fill that comes with size lifting the offer (long) or hitting the bid (short) into the level is the good version; a fill inside a one-minute flush that keeps going is the stop.</a:t>
             </a:r>
           </a:p>
           <a:p>
@@ -3662,7 +3663,7 @@
                 </a:solidFill>
                 <a:latin typeface="Lato"/>
               </a:rPr>
-              <a:t>•  Chart</a:t>
+              <a:t>•  Premarket VWAP</a:t>
             </a:r>
             <a:r>
               <a:rPr sz="1300">
@@ -3671,7 +3672,7 @@
                 </a:solidFill>
                 <a:latin typeface="Lato"/>
               </a:rPr>
-              <a:t> 15-minute with extended hours ON, studies 9-EMA, 34-SMA and VWAP reset at 04:00 (premarket). A regular-hours chart gives a different level and a worse result for this form.</a:t>
+              <a:t> the second reference. For a long, price holding between the 34-SMA and the PM VWAP after the fill is confirmation; a print back below the PM VWAP with the 9-EMA turning is the early warning the 15-minute close will confirm.</a:t>
             </a:r>
           </a:p>
           <a:p>
@@ -3687,7 +3688,7 @@
                 </a:solidFill>
                 <a:latin typeface="Lato"/>
               </a:rPr>
-              <a:t>•  Order</a:t>
+              <a:t>•  The 09:45 close</a:t>
             </a:r>
             <a:r>
               <a:rPr sz="1300">
@@ -3696,7 +3697,7 @@
                 </a:solidFill>
                 <a:latin typeface="Lato"/>
               </a:rPr>
-              <a:t> a bracket placed before 09:30: limit at the 34-SMA value, stop 1.0×ATR away, quantity = 1R ÷ stop distance. In DAS Trader Pro that is one hotkey script; the open-source version is in the repo (scripts/).</a:t>
+              <a:t> the first completed bar. Above the 9-EMA arms the exit and says the drive is real; below it and the trade is living on the stop.</a:t>
             </a:r>
           </a:p>
           <a:p>
@@ -3712,7 +3713,7 @@
                 </a:solidFill>
                 <a:latin typeface="Lato"/>
               </a:rPr>
-              <a:t>•  Exit</a:t>
+              <a:t>•  Level to watch on the tape</a:t>
             </a:r>
             <a:r>
               <a:rPr sz="1300">
@@ -3721,7 +3722,7 @@
                 </a:solidFill>
                 <a:latin typeface="Lato"/>
               </a:rPr>
-              <a:t> watch the 15-minute closes against the 9-EMA; the exit is a market order at the open of the bar after the first close back across it. This can be a chart alert or a script.</a:t>
+              <a:t> the fill price itself. The trade that never comes back to the fill after 09:45 is the runner; the one that keeps testing it is a scratch waiting to happen.</a:t>
             </a:r>
           </a:p>
           <a:p>
@@ -3737,7 +3738,7 @@
                 </a:solidFill>
                 <a:latin typeface="Lato"/>
               </a:rPr>
-              <a:t>•  Backtest</a:t>
+              <a:t>•  Speed</a:t>
             </a:r>
             <a:r>
               <a:rPr sz="1300">
@@ -3746,32 +3747,7 @@
                 </a:solidFill>
                 <a:latin typeface="Lato"/>
               </a:rPr>
-              <a:t> backtest/backtest_sma34_trend.py in the repo reproduces every number in this deck from Massive.com (Polygon) flat files; report in docs/forward-tests/sma34-trend-3y.md.</a:t>
-            </a:r>
-          </a:p>
-          <a:p>
-            <a:pPr>
-              <a:spcAft>
-                <a:spcPts val="800"/>
-              </a:spcAft>
-            </a:pPr>
-            <a:r>
-              <a:rPr sz="1300" b="1">
-                <a:solidFill>
-                  <a:srgbClr val="1A1B26"/>
-                </a:solidFill>
-                <a:latin typeface="Lato"/>
-              </a:rPr>
-              <a:t>•  Safety</a:t>
-            </a:r>
-            <a:r>
-              <a:rPr sz="1300">
-                <a:solidFill>
-                  <a:srgbClr val="1A1B26"/>
-                </a:solidFill>
-                <a:latin typeface="Lato"/>
-              </a:rPr>
-              <a:t> simulation first, one R, until you have measured twenty of your own stop fills against the stop price.</a:t>
+              <a:t> median one minute from fill to stop in the losing form. If the first minute after the fill runs against you, there is no decision to make; the stop makes it.</a:t>
             </a:r>
           </a:p>
         </p:txBody>
@@ -3828,7 +3804,7 @@
                 </a:solidFill>
                 <a:latin typeface="Lato"/>
               </a:rPr>
-              <a:t>TRADE REVIEW</a:t>
+              <a:t>TECHNOLOGY</a:t>
             </a:r>
           </a:p>
         </p:txBody>
@@ -3867,7 +3843,7 @@
                 </a:solidFill>
                 <a:latin typeface="Lato"/>
               </a:rPr>
-              <a:t>What the three years say to do better</a:t>
+              <a:t>Everything the trade needs is scripted; the human job is the 09:15 read and the order</a:t>
             </a:r>
           </a:p>
         </p:txBody>
@@ -3959,6 +3935,353 @@
         <p:spPr>
           <a:xfrm>
             <a:off x="457200" y="1371600"/>
+            <a:ext cx="11247120" cy="4846320"/>
+          </a:xfrm>
+          <a:prstGeom prst="rect">
+            <a:avLst/>
+          </a:prstGeom>
+          <a:noFill/>
+        </p:spPr>
+        <p:txBody>
+          <a:bodyPr wrap="square">
+            <a:spAutoFit/>
+          </a:bodyPr>
+          <a:lstStyle/>
+          <a:p>
+            <a:pPr>
+              <a:spcAft>
+                <a:spcPts val="800"/>
+              </a:spcAft>
+            </a:pPr>
+            <a:r>
+              <a:rPr sz="1300" b="1">
+                <a:solidFill>
+                  <a:srgbClr val="1A1B26"/>
+                </a:solidFill>
+                <a:latin typeface="Lato"/>
+              </a:rPr>
+              <a:t>•  Scan (09:15)</a:t>
+            </a:r>
+            <a:r>
+              <a:rPr sz="1300">
+                <a:solidFill>
+                  <a:srgbClr val="1A1B26"/>
+                </a:solidFill>
+                <a:latin typeface="Lato"/>
+              </a:rPr>
+              <a:t> any scanner that shows premarket volume against the name's own average; the rule is today's premarket volume ÷ the 20-day median premarket volume ≥ 2.</a:t>
+            </a:r>
+          </a:p>
+          <a:p>
+            <a:pPr>
+              <a:spcAft>
+                <a:spcPts val="800"/>
+              </a:spcAft>
+            </a:pPr>
+            <a:r>
+              <a:rPr sz="1300" b="1">
+                <a:solidFill>
+                  <a:srgbClr val="1A1B26"/>
+                </a:solidFill>
+                <a:latin typeface="Lato"/>
+              </a:rPr>
+              <a:t>•  Chart</a:t>
+            </a:r>
+            <a:r>
+              <a:rPr sz="1300">
+                <a:solidFill>
+                  <a:srgbClr val="1A1B26"/>
+                </a:solidFill>
+                <a:latin typeface="Lato"/>
+              </a:rPr>
+              <a:t> 15-minute with extended hours ON, studies 9-EMA, 34-SMA and VWAP reset at 04:00 (premarket). A regular-hours chart gives a different level and a worse result for this form.</a:t>
+            </a:r>
+          </a:p>
+          <a:p>
+            <a:pPr>
+              <a:spcAft>
+                <a:spcPts val="800"/>
+              </a:spcAft>
+            </a:pPr>
+            <a:r>
+              <a:rPr sz="1300" b="1">
+                <a:solidFill>
+                  <a:srgbClr val="1A1B26"/>
+                </a:solidFill>
+                <a:latin typeface="Lato"/>
+              </a:rPr>
+              <a:t>•  Order</a:t>
+            </a:r>
+            <a:r>
+              <a:rPr sz="1300">
+                <a:solidFill>
+                  <a:srgbClr val="1A1B26"/>
+                </a:solidFill>
+                <a:latin typeface="Lato"/>
+              </a:rPr>
+              <a:t> a bracket placed before 09:30: limit at the 34-SMA value, stop 1.0×ATR away, quantity = 1R ÷ stop distance. In DAS Trader Pro that is one hotkey script; the open-source version is in the repo (scripts/).</a:t>
+            </a:r>
+          </a:p>
+          <a:p>
+            <a:pPr>
+              <a:spcAft>
+                <a:spcPts val="800"/>
+              </a:spcAft>
+            </a:pPr>
+            <a:r>
+              <a:rPr sz="1300" b="1">
+                <a:solidFill>
+                  <a:srgbClr val="1A1B26"/>
+                </a:solidFill>
+                <a:latin typeface="Lato"/>
+              </a:rPr>
+              <a:t>•  Exit</a:t>
+            </a:r>
+            <a:r>
+              <a:rPr sz="1300">
+                <a:solidFill>
+                  <a:srgbClr val="1A1B26"/>
+                </a:solidFill>
+                <a:latin typeface="Lato"/>
+              </a:rPr>
+              <a:t> watch the 15-minute closes against the 9-EMA; the exit is a market order at the open of the bar after the first close back across it. This can be a chart alert or a script.</a:t>
+            </a:r>
+          </a:p>
+          <a:p>
+            <a:pPr>
+              <a:spcAft>
+                <a:spcPts val="800"/>
+              </a:spcAft>
+            </a:pPr>
+            <a:r>
+              <a:rPr sz="1300" b="1">
+                <a:solidFill>
+                  <a:srgbClr val="1A1B26"/>
+                </a:solidFill>
+                <a:latin typeface="Lato"/>
+              </a:rPr>
+              <a:t>•  Backtest</a:t>
+            </a:r>
+            <a:r>
+              <a:rPr sz="1300">
+                <a:solidFill>
+                  <a:srgbClr val="1A1B26"/>
+                </a:solidFill>
+                <a:latin typeface="Lato"/>
+              </a:rPr>
+              <a:t> backtest/backtest_sma34_trend.py in the repo reproduces every number in this deck from Massive.com (Polygon) flat files; report in docs/forward-tests/sma34-trend-3y.md.</a:t>
+            </a:r>
+          </a:p>
+          <a:p>
+            <a:pPr>
+              <a:spcAft>
+                <a:spcPts val="800"/>
+              </a:spcAft>
+            </a:pPr>
+            <a:r>
+              <a:rPr sz="1300" b="1">
+                <a:solidFill>
+                  <a:srgbClr val="1A1B26"/>
+                </a:solidFill>
+                <a:latin typeface="Lato"/>
+              </a:rPr>
+              <a:t>•  Safety</a:t>
+            </a:r>
+            <a:r>
+              <a:rPr sz="1300">
+                <a:solidFill>
+                  <a:srgbClr val="1A1B26"/>
+                </a:solidFill>
+                <a:latin typeface="Lato"/>
+              </a:rPr>
+              <a:t> simulation first, one R, until you have measured twenty of your own stop fills against the stop price.</a:t>
+            </a:r>
+          </a:p>
+        </p:txBody>
+      </p:sp>
+    </p:spTree>
+  </p:cSld>
+  <p:clrMapOvr>
+    <a:masterClrMapping/>
+  </p:clrMapOvr>
+</p:sld>
+</file>
+
+<file path=ppt/slides/slide12.xml><?xml version="1.0" encoding="utf-8"?>
+<p:sld xmlns:a="http://schemas.openxmlformats.org/drawingml/2006/main" xmlns:p="http://schemas.openxmlformats.org/presentationml/2006/main" xmlns:r="http://schemas.openxmlformats.org/officeDocument/2006/relationships">
+  <p:cSld>
+    <p:spTree>
+      <p:nvGrpSpPr>
+        <p:cNvPr id="1" name=""/>
+        <p:cNvGrpSpPr/>
+        <p:nvPr/>
+      </p:nvGrpSpPr>
+      <p:grpSpPr/>
+      <p:sp>
+        <p:nvSpPr>
+          <p:cNvPr id="2" name="TextBox 1"/>
+          <p:cNvSpPr txBox="1"/>
+          <p:nvPr/>
+        </p:nvSpPr>
+        <p:spPr>
+          <a:xfrm>
+            <a:off x="457200" y="274320"/>
+            <a:ext cx="11247120" cy="640080"/>
+          </a:xfrm>
+          <a:prstGeom prst="rect">
+            <a:avLst/>
+          </a:prstGeom>
+          <a:noFill/>
+        </p:spPr>
+        <p:txBody>
+          <a:bodyPr wrap="square">
+            <a:spAutoFit/>
+          </a:bodyPr>
+          <a:lstStyle/>
+          <a:p>
+            <a:pPr algn="l">
+              <a:spcAft>
+                <a:spcPts val="400"/>
+              </a:spcAft>
+            </a:pPr>
+            <a:r>
+              <a:rPr sz="2600" b="1">
+                <a:solidFill>
+                  <a:srgbClr val="1A1B26"/>
+                </a:solidFill>
+                <a:latin typeface="Lato"/>
+              </a:rPr>
+              <a:t>TRADE REVIEW</a:t>
+            </a:r>
+          </a:p>
+        </p:txBody>
+      </p:sp>
+      <p:sp>
+        <p:nvSpPr>
+          <p:cNvPr id="3" name="TextBox 2"/>
+          <p:cNvSpPr txBox="1"/>
+          <p:nvPr/>
+        </p:nvSpPr>
+        <p:spPr>
+          <a:xfrm>
+            <a:off x="457200" y="868680"/>
+            <a:ext cx="11247120" cy="365760"/>
+          </a:xfrm>
+          <a:prstGeom prst="rect">
+            <a:avLst/>
+          </a:prstGeom>
+          <a:noFill/>
+        </p:spPr>
+        <p:txBody>
+          <a:bodyPr wrap="square">
+            <a:spAutoFit/>
+          </a:bodyPr>
+          <a:lstStyle/>
+          <a:p>
+            <a:pPr algn="l">
+              <a:spcAft>
+                <a:spcPts val="400"/>
+              </a:spcAft>
+            </a:pPr>
+            <a:r>
+              <a:rPr sz="1200" b="0">
+                <a:solidFill>
+                  <a:srgbClr val="666666"/>
+                </a:solidFill>
+                <a:latin typeface="Lato"/>
+              </a:rPr>
+              <a:t>What the three years say to do better</a:t>
+            </a:r>
+          </a:p>
+        </p:txBody>
+      </p:sp>
+      <p:sp>
+        <p:nvSpPr>
+          <p:cNvPr id="4" name="TextBox 3"/>
+          <p:cNvSpPr txBox="1"/>
+          <p:nvPr/>
+        </p:nvSpPr>
+        <p:spPr>
+          <a:xfrm>
+            <a:off x="457200" y="6400800"/>
+            <a:ext cx="10515600" cy="365760"/>
+          </a:xfrm>
+          <a:prstGeom prst="rect">
+            <a:avLst/>
+          </a:prstGeom>
+          <a:noFill/>
+        </p:spPr>
+        <p:txBody>
+          <a:bodyPr wrap="square">
+            <a:spAutoFit/>
+          </a:bodyPr>
+          <a:lstStyle/>
+          <a:p>
+            <a:pPr algn="l">
+              <a:spcAft>
+                <a:spcPts val="400"/>
+              </a:spcAft>
+            </a:pPr>
+            <a:r>
+              <a:rPr sz="700" b="0">
+                <a:solidFill>
+                  <a:srgbClr val="666666"/>
+                </a:solidFill>
+                <a:latin typeface="Lato"/>
+              </a:rPr>
+              <a:t>Hypothetical backtest results on Massive.com minute data; simulated trades were not executed and do not reflect slippage, commissions or liquidity except where stated. Not investment advice. Trading As Buddies · github.com/TradingAsBuddies/DAS-hotkeys · PlayBook format after SMB Training (not affiliated).</a:t>
+            </a:r>
+          </a:p>
+        </p:txBody>
+      </p:sp>
+      <p:sp>
+        <p:nvSpPr>
+          <p:cNvPr id="5" name="TextBox 4"/>
+          <p:cNvSpPr txBox="1"/>
+          <p:nvPr/>
+        </p:nvSpPr>
+        <p:spPr>
+          <a:xfrm>
+            <a:off x="11247120" y="6400800"/>
+            <a:ext cx="548640" cy="365760"/>
+          </a:xfrm>
+          <a:prstGeom prst="rect">
+            <a:avLst/>
+          </a:prstGeom>
+          <a:noFill/>
+        </p:spPr>
+        <p:txBody>
+          <a:bodyPr wrap="square">
+            <a:spAutoFit/>
+          </a:bodyPr>
+          <a:lstStyle/>
+          <a:p>
+            <a:pPr algn="r">
+              <a:spcAft>
+                <a:spcPts val="400"/>
+              </a:spcAft>
+            </a:pPr>
+            <a:r>
+              <a:rPr sz="800" b="0">
+                <a:solidFill>
+                  <a:srgbClr val="666666"/>
+                </a:solidFill>
+                <a:latin typeface="Lato"/>
+              </a:rPr>
+              <a:t>12</a:t>
+            </a:r>
+          </a:p>
+        </p:txBody>
+      </p:sp>
+      <p:sp>
+        <p:nvSpPr>
+          <p:cNvPr id="6" name="TextBox 5"/>
+          <p:cNvSpPr txBox="1"/>
+          <p:nvPr/>
+        </p:nvSpPr>
+        <p:spPr>
+          <a:xfrm>
+            <a:off x="457200" y="1371600"/>
             <a:ext cx="6949440" cy="4846320"/>
           </a:xfrm>
           <a:prstGeom prst="rect">
@@ -4009,7 +4332,7 @@
                 </a:solidFill>
                 <a:latin typeface="Lato"/>
               </a:rPr>
-              <a:t>•  Two changes made it</a:t>
+              <a:t>•  Three changes made it</a:t>
             </a:r>
             <a:r>
               <a:rPr sz="1200">
@@ -4018,7 +4341,7 @@
                 </a:solidFill>
                 <a:latin typeface="Lato"/>
               </a:rPr>
-              <a:t> a trailing exit on the 9-EMA close instead of the target, and a stop outside the opening minute's range. Together they are the only positive pre-open form found.</a:t>
+              <a:t> a trailing exit on the 9-EMA close instead of the target, a stop outside the opening minute's range, and no earnings or 8-K mornings. Together they are the only positive pre-open form found.</a:t>
             </a:r>
           </a:p>
           <a:p>
@@ -4155,7 +4478,7 @@
 </p:sld>
 </file>
 
-<file path=ppt/slides/slide12.xml><?xml version="1.0" encoding="utf-8"?>
+<file path=ppt/slides/slide13.xml><?xml version="1.0" encoding="utf-8"?>
 <p:sld xmlns:a="http://schemas.openxmlformats.org/drawingml/2006/main" xmlns:p="http://schemas.openxmlformats.org/presentationml/2006/main" xmlns:r="http://schemas.openxmlformats.org/officeDocument/2006/relationships">
   <p:cSld>
     <p:spTree>
@@ -4316,7 +4639,7 @@
                 </a:solidFill>
                 <a:latin typeface="Lato"/>
               </a:rPr>
-              <a:t>12</a:t>
+              <a:t>13</a:t>
             </a:r>
           </a:p>
         </p:txBody>
@@ -4871,7 +5194,7 @@
 </p:sld>
 </file>
 
-<file path=ppt/slides/slide13.xml><?xml version="1.0" encoding="utf-8"?>
+<file path=ppt/slides/slide14.xml><?xml version="1.0" encoding="utf-8"?>
 <p:sld xmlns:a="http://schemas.openxmlformats.org/drawingml/2006/main" xmlns:p="http://schemas.openxmlformats.org/presentationml/2006/main" xmlns:r="http://schemas.openxmlformats.org/officeDocument/2006/relationships">
   <p:cSld>
     <p:spTree>
@@ -5032,7 +5355,7 @@
                 </a:solidFill>
                 <a:latin typeface="Lato"/>
               </a:rPr>
-              <a:t>13</a:t>
+              <a:t>14</a:t>
             </a:r>
           </a:p>
         </p:txBody>
@@ -5231,7 +5554,7 @@
                           </a:solidFill>
                           <a:latin typeface="Lato"/>
                         </a:rPr>
-                        <a:t>7</a:t>
+                        <a:t>8</a:t>
                       </a:r>
                     </a:p>
                   </a:txBody>
@@ -5253,7 +5576,7 @@
                           </a:solidFill>
                           <a:latin typeface="Lato"/>
                         </a:rPr>
-                        <a:t>One clean, testable filter (premarket volume ratio); no news or catalyst layer yet.</a:t>
+                        <a:t>Premarket volume ratio plus an EDGAR check: earnings and 8-K mornings are excluded on evidence.</a:t>
                       </a:r>
                     </a:p>
                   </a:txBody>
@@ -6436,6 +6759,31 @@
                 <a:latin typeface="Lato"/>
               </a:rPr>
               <a:t> the only stock-selection filter. Two to three times is the sweet spot; above five it trades worse.</a:t>
+            </a:r>
+          </a:p>
+          <a:p>
+            <a:pPr>
+              <a:spcAft>
+                <a:spcPts val="800"/>
+              </a:spcAft>
+            </a:pPr>
+            <a:r>
+              <a:rPr sz="1400" b="1">
+                <a:solidFill>
+                  <a:srgbClr val="1A1B26"/>
+                </a:solidFill>
+                <a:latin typeface="Lato"/>
+              </a:rPr>
+              <a:t>•  No earnings, no 8-K</a:t>
+            </a:r>
+            <a:r>
+              <a:rPr sz="1400">
+                <a:solidFill>
+                  <a:srgbClr val="1A1B26"/>
+                </a:solidFill>
+                <a:latin typeface="Lato"/>
+              </a:rPr>
+              <a:t> RKLB had not reported and had no 8-K in the prior 24 hours. That matters: 84% of earnings mornings pass the premarket filter, and they lose (58 trades, −16R). The heavy premarket this play wants is a sympathy move, an upgrade or a sector headline, not the company's own report.</a:t>
             </a:r>
           </a:p>
           <a:p>
@@ -7660,7 +8008,7 @@
                 </a:solidFill>
                 <a:latin typeface="Lato"/>
               </a:rPr>
-              <a:t>TRADE STRATEGY</a:t>
+              <a:t>INTRADAY FUNDAMENTALS: CATALYSTS</a:t>
             </a:r>
           </a:p>
         </p:txBody>
@@ -7699,7 +8047,7 @@
                 </a:solidFill>
                 <a:latin typeface="Lato"/>
               </a:rPr>
-              <a:t>The rule, as backtested (backtest/backtest_sma34_trend.py --preopen --gate 09:30 --exit-ema9-close --target-r 0 --stop-mult 1.0)</a:t>
+              <a:t>SEC EDGAR 8-K filings joined to every trade day · earnings mornings are the losing subset</a:t>
             </a:r>
           </a:p>
         </p:txBody>
@@ -7782,16 +8130,40 @@
           </a:p>
         </p:txBody>
       </p:sp>
-      <p:sp>
-        <p:nvSpPr>
-          <p:cNvPr id="6" name="TextBox 5"/>
+      <p:pic>
+        <p:nvPicPr>
+          <p:cNvPr id="6" name="Picture 5" descr="sma34_catalyst.png"/>
+          <p:cNvPicPr>
+            <a:picLocks noChangeAspect="1"/>
+          </p:cNvPicPr>
+          <p:nvPr/>
+        </p:nvPicPr>
+        <p:blipFill>
+          <a:blip r:embed="rId2"/>
+          <a:stretch>
+            <a:fillRect/>
+          </a:stretch>
+        </p:blipFill>
+        <p:spPr>
+          <a:xfrm>
+            <a:off x="457200" y="1325880"/>
+            <a:ext cx="10789920" cy="4119788"/>
+          </a:xfrm>
+          <a:prstGeom prst="rect">
+            <a:avLst/>
+          </a:prstGeom>
+        </p:spPr>
+      </p:pic>
+      <p:sp>
+        <p:nvSpPr>
+          <p:cNvPr id="7" name="TextBox 6"/>
           <p:cNvSpPr txBox="1"/>
           <p:nvPr/>
         </p:nvSpPr>
         <p:spPr>
           <a:xfrm>
-            <a:off x="457200" y="1371600"/>
-            <a:ext cx="11247120" cy="4846320"/>
+            <a:off x="457200" y="5486400"/>
+            <a:ext cx="11247120" cy="822960"/>
           </a:xfrm>
           <a:prstGeom prst="rect">
             <a:avLst/>
@@ -7804,203 +8176,19 @@
           </a:bodyPr>
           <a:lstStyle/>
           <a:p>
-            <a:pPr>
+            <a:pPr algn="l">
               <a:spcAft>
-                <a:spcPts val="800"/>
+                <a:spcPts val="400"/>
               </a:spcAft>
             </a:pPr>
             <a:r>
-              <a:rPr sz="1300" b="1">
-                <a:solidFill>
-                  <a:srgbClr val="1A1B26"/>
-                </a:solidFill>
-                <a:latin typeface="Lato"/>
-              </a:rPr>
-              <a:t>•  Scan 09:15</a:t>
-            </a:r>
-            <a:r>
-              <a:rPr sz="1300">
-                <a:solidFill>
-                  <a:srgbClr val="1A1B26"/>
-                </a:solidFill>
-                <a:latin typeface="Lato"/>
-              </a:rPr>
-              <a:t> premarket volume ≥ 2× the name's 20-day median premarket volume. Skip names above 5× (they trade worse) and anything sub-$10 or post reverse-split.</a:t>
-            </a:r>
-          </a:p>
-          <a:p>
-            <a:pPr>
-              <a:spcAft>
-                <a:spcPts val="800"/>
-              </a:spcAft>
-            </a:pPr>
-            <a:r>
-              <a:rPr sz="1300" b="1">
-                <a:solidFill>
-                  <a:srgbClr val="1A1B26"/>
-                </a:solidFill>
-                <a:latin typeface="Lato"/>
-              </a:rPr>
-              <a:t>•  Direction</a:t>
-            </a:r>
-            <a:r>
-              <a:rPr sz="1300">
-                <a:solidFill>
-                  <a:srgbClr val="1A1B26"/>
-                </a:solidFill>
-                <a:latin typeface="Lato"/>
-              </a:rPr>
-              <a:t> 9-EMA on the extended-hours 15-minute chart above the premarket VWAP → long; below → short.</a:t>
-            </a:r>
-          </a:p>
-          <a:p>
-            <a:pPr>
-              <a:spcAft>
-                <a:spcPts val="800"/>
-              </a:spcAft>
-            </a:pPr>
-            <a:r>
-              <a:rPr sz="1300" b="1">
-                <a:solidFill>
-                  <a:srgbClr val="1A1B26"/>
-                </a:solidFill>
-                <a:latin typeface="Lato"/>
-              </a:rPr>
-              <a:t>•  Order</a:t>
-            </a:r>
-            <a:r>
-              <a:rPr sz="1300">
-                <a:solidFill>
-                  <a:srgbClr val="1A1B26"/>
-                </a:solidFill>
-                <a:latin typeface="Lato"/>
-              </a:rPr>
-              <a:t> limit at the 34-SMA value of the last completed 15-minute bar before 09:30. Only if the 09:29 price is on the trade side of it (buy below the market, sell short above it).</a:t>
-            </a:r>
-          </a:p>
-          <a:p>
-            <a:pPr>
-              <a:spcAft>
-                <a:spcPts val="800"/>
-              </a:spcAft>
-            </a:pPr>
-            <a:r>
-              <a:rPr sz="1300" b="1">
-                <a:solidFill>
-                  <a:srgbClr val="1A1B26"/>
-                </a:solidFill>
-                <a:latin typeface="Lato"/>
-              </a:rPr>
-              <a:t>•  Stop</a:t>
-            </a:r>
-            <a:r>
-              <a:rPr sz="1300">
-                <a:solidFill>
-                  <a:srgbClr val="1A1B26"/>
-                </a:solidFill>
-                <a:latin typeface="Lato"/>
-              </a:rPr>
-              <a:t> 1.0 × ATR(14) of the 15-minute chart, entered with the order as a bracket.</a:t>
-            </a:r>
-          </a:p>
-          <a:p>
-            <a:pPr>
-              <a:spcAft>
-                <a:spcPts val="800"/>
-              </a:spcAft>
-            </a:pPr>
-            <a:r>
-              <a:rPr sz="1300" b="1">
-                <a:solidFill>
-                  <a:srgbClr val="1A1B26"/>
-                </a:solidFill>
-                <a:latin typeface="Lato"/>
-              </a:rPr>
-              <a:t>•  Target</a:t>
-            </a:r>
-            <a:r>
-              <a:rPr sz="1300">
-                <a:solidFill>
-                  <a:srgbClr val="1A1B26"/>
-                </a:solidFill>
-                <a:latin typeface="Lato"/>
-              </a:rPr>
-              <a:t> none. Exit on the first 15-minute bar that closes back across the 9-EMA, after at least one bar has closed with the trade.</a:t>
-            </a:r>
-          </a:p>
-          <a:p>
-            <a:pPr>
-              <a:spcAft>
-                <a:spcPts val="800"/>
-              </a:spcAft>
-            </a:pPr>
-            <a:r>
-              <a:rPr sz="1300" b="1">
-                <a:solidFill>
-                  <a:srgbClr val="1A1B26"/>
-                </a:solidFill>
-                <a:latin typeface="Lato"/>
-              </a:rPr>
-              <a:t>•  Time</a:t>
-            </a:r>
-            <a:r>
-              <a:rPr sz="1300">
-                <a:solidFill>
-                  <a:srgbClr val="1A1B26"/>
-                </a:solidFill>
-                <a:latin typeface="Lato"/>
-              </a:rPr>
-              <a:t> order live 09:30 to 15:00; anything still open is flat at 15:55. One entry per name per day. Simplest form: one position a day, in the name with the heaviest premarket (+32R on 230 trades).</a:t>
-            </a:r>
-          </a:p>
-          <a:p>
-            <a:pPr>
-              <a:spcAft>
-                <a:spcPts val="800"/>
-              </a:spcAft>
-            </a:pPr>
-            <a:r>
-              <a:rPr sz="1300" b="1">
-                <a:solidFill>
-                  <a:srgbClr val="1A1B26"/>
-                </a:solidFill>
-                <a:latin typeface="Lato"/>
-              </a:rPr>
-              <a:t>•  Size</a:t>
-            </a:r>
-            <a:r>
-              <a:rPr sz="1300">
-                <a:solidFill>
-                  <a:srgbClr val="1A1B26"/>
-                </a:solidFill>
-                <a:latin typeface="Lato"/>
-              </a:rPr>
-              <a:t> shares = 1R ÷ stop distance, where 1R is the amount you risk per trade (we test at a tenth of a percent of capital). Cap size to what the name's liquidity fills cleanly.</a:t>
-            </a:r>
-          </a:p>
-          <a:p>
-            <a:pPr>
-              <a:spcAft>
-                <a:spcPts val="800"/>
-              </a:spcAft>
-            </a:pPr>
-            <a:r>
-              <a:rPr sz="1300" b="1">
-                <a:solidFill>
-                  <a:srgbClr val="1A1B26"/>
-                </a:solidFill>
-                <a:latin typeface="Lato"/>
-              </a:rPr>
-              <a:t>•  Do not</a:t>
-            </a:r>
-            <a:r>
-              <a:rPr sz="1300">
-                <a:solidFill>
-                  <a:srgbClr val="1A1B26"/>
-                </a:solidFill>
-                <a:latin typeface="Lato"/>
-              </a:rPr>
-              <a:t> re-price the order intraday, take a second fill, or hold a name that never closes a 15-minute bar with the trade past 12:00.</a:t>
+              <a:rPr sz="1100" b="0">
+                <a:solidFill>
+                  <a:srgbClr val="666666"/>
+                </a:solidFill>
+                <a:latin typeface="Lato"/>
+              </a:rPr>
+              <a:t>Earnings and other-8-K reaction days: 106 trades, −27R, −0.26R each. Every other day: 627 trades, +114R, +0.18R each, max drawdown 26.7R, +69R after 5¢ of stop slippage. The chance that a random 106-trade subset does this badly is under 2%.</a:t>
             </a:r>
           </a:p>
         </p:txBody>
@@ -8057,7 +8245,7 @@
                 </a:solidFill>
                 <a:latin typeface="Lato"/>
               </a:rPr>
-              <a:t>TRADE MANAGEMENT</a:t>
+              <a:t>TRADE STRATEGY</a:t>
             </a:r>
           </a:p>
         </p:txBody>
@@ -8096,7 +8284,7 @@
                 </a:solidFill>
                 <a:latin typeface="Lato"/>
               </a:rPr>
-              <a:t>RKLB 2026-05-11 as it was simulated</a:t>
+              <a:t>The rule, as backtested (backtest/backtest_sma34_trend.py --preopen --gate 09:30 --exit-ema9-close --target-r 0 --stop-mult 1.0)</a:t>
             </a:r>
           </a:p>
         </p:txBody>
@@ -8175,6 +8363,403 @@
                 <a:latin typeface="Lato"/>
               </a:rPr>
               <a:t>8</a:t>
+            </a:r>
+          </a:p>
+        </p:txBody>
+      </p:sp>
+      <p:sp>
+        <p:nvSpPr>
+          <p:cNvPr id="6" name="TextBox 5"/>
+          <p:cNvSpPr txBox="1"/>
+          <p:nvPr/>
+        </p:nvSpPr>
+        <p:spPr>
+          <a:xfrm>
+            <a:off x="457200" y="1371600"/>
+            <a:ext cx="11247120" cy="4846320"/>
+          </a:xfrm>
+          <a:prstGeom prst="rect">
+            <a:avLst/>
+          </a:prstGeom>
+          <a:noFill/>
+        </p:spPr>
+        <p:txBody>
+          <a:bodyPr wrap="square">
+            <a:spAutoFit/>
+          </a:bodyPr>
+          <a:lstStyle/>
+          <a:p>
+            <a:pPr>
+              <a:spcAft>
+                <a:spcPts val="800"/>
+              </a:spcAft>
+            </a:pPr>
+            <a:r>
+              <a:rPr sz="1300" b="1">
+                <a:solidFill>
+                  <a:srgbClr val="1A1B26"/>
+                </a:solidFill>
+                <a:latin typeface="Lato"/>
+              </a:rPr>
+              <a:t>•  Scan 09:15</a:t>
+            </a:r>
+            <a:r>
+              <a:rPr sz="1300">
+                <a:solidFill>
+                  <a:srgbClr val="1A1B26"/>
+                </a:solidFill>
+                <a:latin typeface="Lato"/>
+              </a:rPr>
+              <a:t> premarket volume ≥ 2× the name's 20-day median premarket volume. Skip names above 5× (they trade worse), anything sub-$10 or post reverse-split, and any name that reported earnings or filed an 8-K in the prior 24 hours.</a:t>
+            </a:r>
+          </a:p>
+          <a:p>
+            <a:pPr>
+              <a:spcAft>
+                <a:spcPts val="800"/>
+              </a:spcAft>
+            </a:pPr>
+            <a:r>
+              <a:rPr sz="1300" b="1">
+                <a:solidFill>
+                  <a:srgbClr val="1A1B26"/>
+                </a:solidFill>
+                <a:latin typeface="Lato"/>
+              </a:rPr>
+              <a:t>•  Direction</a:t>
+            </a:r>
+            <a:r>
+              <a:rPr sz="1300">
+                <a:solidFill>
+                  <a:srgbClr val="1A1B26"/>
+                </a:solidFill>
+                <a:latin typeface="Lato"/>
+              </a:rPr>
+              <a:t> 9-EMA on the extended-hours 15-minute chart above the premarket VWAP → long; below → short.</a:t>
+            </a:r>
+          </a:p>
+          <a:p>
+            <a:pPr>
+              <a:spcAft>
+                <a:spcPts val="800"/>
+              </a:spcAft>
+            </a:pPr>
+            <a:r>
+              <a:rPr sz="1300" b="1">
+                <a:solidFill>
+                  <a:srgbClr val="1A1B26"/>
+                </a:solidFill>
+                <a:latin typeface="Lato"/>
+              </a:rPr>
+              <a:t>•  Order</a:t>
+            </a:r>
+            <a:r>
+              <a:rPr sz="1300">
+                <a:solidFill>
+                  <a:srgbClr val="1A1B26"/>
+                </a:solidFill>
+                <a:latin typeface="Lato"/>
+              </a:rPr>
+              <a:t> limit at the 34-SMA value of the last completed 15-minute bar before 09:30. Only if the 09:29 price is on the trade side of it (buy below the market, sell short above it).</a:t>
+            </a:r>
+          </a:p>
+          <a:p>
+            <a:pPr>
+              <a:spcAft>
+                <a:spcPts val="800"/>
+              </a:spcAft>
+            </a:pPr>
+            <a:r>
+              <a:rPr sz="1300" b="1">
+                <a:solidFill>
+                  <a:srgbClr val="1A1B26"/>
+                </a:solidFill>
+                <a:latin typeface="Lato"/>
+              </a:rPr>
+              <a:t>•  Stop</a:t>
+            </a:r>
+            <a:r>
+              <a:rPr sz="1300">
+                <a:solidFill>
+                  <a:srgbClr val="1A1B26"/>
+                </a:solidFill>
+                <a:latin typeface="Lato"/>
+              </a:rPr>
+              <a:t> 1.0 × ATR(14) of the 15-minute chart, entered with the order as a bracket.</a:t>
+            </a:r>
+          </a:p>
+          <a:p>
+            <a:pPr>
+              <a:spcAft>
+                <a:spcPts val="800"/>
+              </a:spcAft>
+            </a:pPr>
+            <a:r>
+              <a:rPr sz="1300" b="1">
+                <a:solidFill>
+                  <a:srgbClr val="1A1B26"/>
+                </a:solidFill>
+                <a:latin typeface="Lato"/>
+              </a:rPr>
+              <a:t>•  Target</a:t>
+            </a:r>
+            <a:r>
+              <a:rPr sz="1300">
+                <a:solidFill>
+                  <a:srgbClr val="1A1B26"/>
+                </a:solidFill>
+                <a:latin typeface="Lato"/>
+              </a:rPr>
+              <a:t> none. Exit on the first 15-minute bar that closes back across the 9-EMA, after at least one bar has closed with the trade.</a:t>
+            </a:r>
+          </a:p>
+          <a:p>
+            <a:pPr>
+              <a:spcAft>
+                <a:spcPts val="800"/>
+              </a:spcAft>
+            </a:pPr>
+            <a:r>
+              <a:rPr sz="1300" b="1">
+                <a:solidFill>
+                  <a:srgbClr val="1A1B26"/>
+                </a:solidFill>
+                <a:latin typeface="Lato"/>
+              </a:rPr>
+              <a:t>•  Time</a:t>
+            </a:r>
+            <a:r>
+              <a:rPr sz="1300">
+                <a:solidFill>
+                  <a:srgbClr val="1A1B26"/>
+                </a:solidFill>
+                <a:latin typeface="Lato"/>
+              </a:rPr>
+              <a:t> order live 09:30 to 15:00; anything still open is flat at 15:55. One entry per name per day. Simplest form: one position a day, in the name with the heaviest premarket (+32R on 230 trades).</a:t>
+            </a:r>
+          </a:p>
+          <a:p>
+            <a:pPr>
+              <a:spcAft>
+                <a:spcPts val="800"/>
+              </a:spcAft>
+            </a:pPr>
+            <a:r>
+              <a:rPr sz="1300" b="1">
+                <a:solidFill>
+                  <a:srgbClr val="1A1B26"/>
+                </a:solidFill>
+                <a:latin typeface="Lato"/>
+              </a:rPr>
+              <a:t>•  Size</a:t>
+            </a:r>
+            <a:r>
+              <a:rPr sz="1300">
+                <a:solidFill>
+                  <a:srgbClr val="1A1B26"/>
+                </a:solidFill>
+                <a:latin typeface="Lato"/>
+              </a:rPr>
+              <a:t> shares = 1R ÷ stop distance, where 1R is the amount you risk per trade (we test at a tenth of a percent of capital). Cap size to what the name's liquidity fills cleanly.</a:t>
+            </a:r>
+          </a:p>
+          <a:p>
+            <a:pPr>
+              <a:spcAft>
+                <a:spcPts val="800"/>
+              </a:spcAft>
+            </a:pPr>
+            <a:r>
+              <a:rPr sz="1300" b="1">
+                <a:solidFill>
+                  <a:srgbClr val="1A1B26"/>
+                </a:solidFill>
+                <a:latin typeface="Lato"/>
+              </a:rPr>
+              <a:t>•  Do not</a:t>
+            </a:r>
+            <a:r>
+              <a:rPr sz="1300">
+                <a:solidFill>
+                  <a:srgbClr val="1A1B26"/>
+                </a:solidFill>
+                <a:latin typeface="Lato"/>
+              </a:rPr>
+              <a:t> re-price the order intraday, take a second fill, or hold a name that never closes a 15-minute bar with the trade past 12:00.</a:t>
+            </a:r>
+          </a:p>
+        </p:txBody>
+      </p:sp>
+    </p:spTree>
+  </p:cSld>
+  <p:clrMapOvr>
+    <a:masterClrMapping/>
+  </p:clrMapOvr>
+</p:sld>
+</file>
+
+<file path=ppt/slides/slide9.xml><?xml version="1.0" encoding="utf-8"?>
+<p:sld xmlns:a="http://schemas.openxmlformats.org/drawingml/2006/main" xmlns:p="http://schemas.openxmlformats.org/presentationml/2006/main" xmlns:r="http://schemas.openxmlformats.org/officeDocument/2006/relationships">
+  <p:cSld>
+    <p:spTree>
+      <p:nvGrpSpPr>
+        <p:cNvPr id="1" name=""/>
+        <p:cNvGrpSpPr/>
+        <p:nvPr/>
+      </p:nvGrpSpPr>
+      <p:grpSpPr/>
+      <p:sp>
+        <p:nvSpPr>
+          <p:cNvPr id="2" name="TextBox 1"/>
+          <p:cNvSpPr txBox="1"/>
+          <p:nvPr/>
+        </p:nvSpPr>
+        <p:spPr>
+          <a:xfrm>
+            <a:off x="457200" y="274320"/>
+            <a:ext cx="11247120" cy="640080"/>
+          </a:xfrm>
+          <a:prstGeom prst="rect">
+            <a:avLst/>
+          </a:prstGeom>
+          <a:noFill/>
+        </p:spPr>
+        <p:txBody>
+          <a:bodyPr wrap="square">
+            <a:spAutoFit/>
+          </a:bodyPr>
+          <a:lstStyle/>
+          <a:p>
+            <a:pPr algn="l">
+              <a:spcAft>
+                <a:spcPts val="400"/>
+              </a:spcAft>
+            </a:pPr>
+            <a:r>
+              <a:rPr sz="2600" b="1">
+                <a:solidFill>
+                  <a:srgbClr val="1A1B26"/>
+                </a:solidFill>
+                <a:latin typeface="Lato"/>
+              </a:rPr>
+              <a:t>TRADE MANAGEMENT</a:t>
+            </a:r>
+          </a:p>
+        </p:txBody>
+      </p:sp>
+      <p:sp>
+        <p:nvSpPr>
+          <p:cNvPr id="3" name="TextBox 2"/>
+          <p:cNvSpPr txBox="1"/>
+          <p:nvPr/>
+        </p:nvSpPr>
+        <p:spPr>
+          <a:xfrm>
+            <a:off x="457200" y="868680"/>
+            <a:ext cx="11247120" cy="365760"/>
+          </a:xfrm>
+          <a:prstGeom prst="rect">
+            <a:avLst/>
+          </a:prstGeom>
+          <a:noFill/>
+        </p:spPr>
+        <p:txBody>
+          <a:bodyPr wrap="square">
+            <a:spAutoFit/>
+          </a:bodyPr>
+          <a:lstStyle/>
+          <a:p>
+            <a:pPr algn="l">
+              <a:spcAft>
+                <a:spcPts val="400"/>
+              </a:spcAft>
+            </a:pPr>
+            <a:r>
+              <a:rPr sz="1200" b="0">
+                <a:solidFill>
+                  <a:srgbClr val="666666"/>
+                </a:solidFill>
+                <a:latin typeface="Lato"/>
+              </a:rPr>
+              <a:t>RKLB 2026-05-11 as it was simulated</a:t>
+            </a:r>
+          </a:p>
+        </p:txBody>
+      </p:sp>
+      <p:sp>
+        <p:nvSpPr>
+          <p:cNvPr id="4" name="TextBox 3"/>
+          <p:cNvSpPr txBox="1"/>
+          <p:nvPr/>
+        </p:nvSpPr>
+        <p:spPr>
+          <a:xfrm>
+            <a:off x="457200" y="6400800"/>
+            <a:ext cx="10515600" cy="365760"/>
+          </a:xfrm>
+          <a:prstGeom prst="rect">
+            <a:avLst/>
+          </a:prstGeom>
+          <a:noFill/>
+        </p:spPr>
+        <p:txBody>
+          <a:bodyPr wrap="square">
+            <a:spAutoFit/>
+          </a:bodyPr>
+          <a:lstStyle/>
+          <a:p>
+            <a:pPr algn="l">
+              <a:spcAft>
+                <a:spcPts val="400"/>
+              </a:spcAft>
+            </a:pPr>
+            <a:r>
+              <a:rPr sz="700" b="0">
+                <a:solidFill>
+                  <a:srgbClr val="666666"/>
+                </a:solidFill>
+                <a:latin typeface="Lato"/>
+              </a:rPr>
+              <a:t>Hypothetical backtest results on Massive.com minute data; simulated trades were not executed and do not reflect slippage, commissions or liquidity except where stated. Not investment advice. Trading As Buddies · github.com/TradingAsBuddies/DAS-hotkeys · PlayBook format after SMB Training (not affiliated).</a:t>
+            </a:r>
+          </a:p>
+        </p:txBody>
+      </p:sp>
+      <p:sp>
+        <p:nvSpPr>
+          <p:cNvPr id="5" name="TextBox 4"/>
+          <p:cNvSpPr txBox="1"/>
+          <p:nvPr/>
+        </p:nvSpPr>
+        <p:spPr>
+          <a:xfrm>
+            <a:off x="11247120" y="6400800"/>
+            <a:ext cx="548640" cy="365760"/>
+          </a:xfrm>
+          <a:prstGeom prst="rect">
+            <a:avLst/>
+          </a:prstGeom>
+          <a:noFill/>
+        </p:spPr>
+        <p:txBody>
+          <a:bodyPr wrap="square">
+            <a:spAutoFit/>
+          </a:bodyPr>
+          <a:lstStyle/>
+          <a:p>
+            <a:pPr algn="r">
+              <a:spcAft>
+                <a:spcPts val="400"/>
+              </a:spcAft>
+            </a:pPr>
+            <a:r>
+              <a:rPr sz="800" b="0">
+                <a:solidFill>
+                  <a:srgbClr val="666666"/>
+                </a:solidFill>
+                <a:latin typeface="Lato"/>
+              </a:rPr>
+              <a:t>9</a:t>
             </a:r>
           </a:p>
         </p:txBody>
@@ -8986,328 +9571,6 @@
                 <a:latin typeface="Lato"/>
               </a:rPr>
               <a:t> 513 of 733 exits are stops. Five cents of adverse slippage per stop turns +86R into +35R; measure the first twenty live stops before sizing above 1R.</a:t>
-            </a:r>
-          </a:p>
-        </p:txBody>
-      </p:sp>
-    </p:spTree>
-  </p:cSld>
-  <p:clrMapOvr>
-    <a:masterClrMapping/>
-  </p:clrMapOvr>
-</p:sld>
-</file>
-
-<file path=ppt/slides/slide9.xml><?xml version="1.0" encoding="utf-8"?>
-<p:sld xmlns:a="http://schemas.openxmlformats.org/drawingml/2006/main" xmlns:p="http://schemas.openxmlformats.org/presentationml/2006/main" xmlns:r="http://schemas.openxmlformats.org/officeDocument/2006/relationships">
-  <p:cSld>
-    <p:spTree>
-      <p:nvGrpSpPr>
-        <p:cNvPr id="1" name=""/>
-        <p:cNvGrpSpPr/>
-        <p:nvPr/>
-      </p:nvGrpSpPr>
-      <p:grpSpPr/>
-      <p:sp>
-        <p:nvSpPr>
-          <p:cNvPr id="2" name="TextBox 1"/>
-          <p:cNvSpPr txBox="1"/>
-          <p:nvPr/>
-        </p:nvSpPr>
-        <p:spPr>
-          <a:xfrm>
-            <a:off x="457200" y="274320"/>
-            <a:ext cx="11247120" cy="640080"/>
-          </a:xfrm>
-          <a:prstGeom prst="rect">
-            <a:avLst/>
-          </a:prstGeom>
-          <a:noFill/>
-        </p:spPr>
-        <p:txBody>
-          <a:bodyPr wrap="square">
-            <a:spAutoFit/>
-          </a:bodyPr>
-          <a:lstStyle/>
-          <a:p>
-            <a:pPr algn="l">
-              <a:spcAft>
-                <a:spcPts val="400"/>
-              </a:spcAft>
-            </a:pPr>
-            <a:r>
-              <a:rPr sz="2600" b="1">
-                <a:solidFill>
-                  <a:srgbClr val="1A1B26"/>
-                </a:solidFill>
-                <a:latin typeface="Lato"/>
-              </a:rPr>
-              <a:t>READING THE TAPE</a:t>
-            </a:r>
-          </a:p>
-        </p:txBody>
-      </p:sp>
-      <p:sp>
-        <p:nvSpPr>
-          <p:cNvPr id="3" name="TextBox 2"/>
-          <p:cNvSpPr txBox="1"/>
-          <p:nvPr/>
-        </p:nvSpPr>
-        <p:spPr>
-          <a:xfrm>
-            <a:off x="457200" y="868680"/>
-            <a:ext cx="11247120" cy="365760"/>
-          </a:xfrm>
-          <a:prstGeom prst="rect">
-            <a:avLst/>
-          </a:prstGeom>
-          <a:noFill/>
-        </p:spPr>
-        <p:txBody>
-          <a:bodyPr wrap="square">
-            <a:spAutoFit/>
-          </a:bodyPr>
-          <a:lstStyle/>
-          <a:p>
-            <a:pPr algn="l">
-              <a:spcAft>
-                <a:spcPts val="400"/>
-              </a:spcAft>
-            </a:pPr>
-            <a:r>
-              <a:rPr sz="1200" b="0">
-                <a:solidFill>
-                  <a:srgbClr val="666666"/>
-                </a:solidFill>
-                <a:latin typeface="Lato"/>
-              </a:rPr>
-              <a:t>What to watch at the level between 09:30 and 10:00</a:t>
-            </a:r>
-          </a:p>
-        </p:txBody>
-      </p:sp>
-      <p:sp>
-        <p:nvSpPr>
-          <p:cNvPr id="4" name="TextBox 3"/>
-          <p:cNvSpPr txBox="1"/>
-          <p:nvPr/>
-        </p:nvSpPr>
-        <p:spPr>
-          <a:xfrm>
-            <a:off x="457200" y="6400800"/>
-            <a:ext cx="10515600" cy="365760"/>
-          </a:xfrm>
-          <a:prstGeom prst="rect">
-            <a:avLst/>
-          </a:prstGeom>
-          <a:noFill/>
-        </p:spPr>
-        <p:txBody>
-          <a:bodyPr wrap="square">
-            <a:spAutoFit/>
-          </a:bodyPr>
-          <a:lstStyle/>
-          <a:p>
-            <a:pPr algn="l">
-              <a:spcAft>
-                <a:spcPts val="400"/>
-              </a:spcAft>
-            </a:pPr>
-            <a:r>
-              <a:rPr sz="700" b="0">
-                <a:solidFill>
-                  <a:srgbClr val="666666"/>
-                </a:solidFill>
-                <a:latin typeface="Lato"/>
-              </a:rPr>
-              <a:t>Hypothetical backtest results on Massive.com minute data; simulated trades were not executed and do not reflect slippage, commissions or liquidity except where stated. Not investment advice. Trading As Buddies · github.com/TradingAsBuddies/DAS-hotkeys · PlayBook format after SMB Training (not affiliated).</a:t>
-            </a:r>
-          </a:p>
-        </p:txBody>
-      </p:sp>
-      <p:sp>
-        <p:nvSpPr>
-          <p:cNvPr id="5" name="TextBox 4"/>
-          <p:cNvSpPr txBox="1"/>
-          <p:nvPr/>
-        </p:nvSpPr>
-        <p:spPr>
-          <a:xfrm>
-            <a:off x="11247120" y="6400800"/>
-            <a:ext cx="548640" cy="365760"/>
-          </a:xfrm>
-          <a:prstGeom prst="rect">
-            <a:avLst/>
-          </a:prstGeom>
-          <a:noFill/>
-        </p:spPr>
-        <p:txBody>
-          <a:bodyPr wrap="square">
-            <a:spAutoFit/>
-          </a:bodyPr>
-          <a:lstStyle/>
-          <a:p>
-            <a:pPr algn="r">
-              <a:spcAft>
-                <a:spcPts val="400"/>
-              </a:spcAft>
-            </a:pPr>
-            <a:r>
-              <a:rPr sz="800" b="0">
-                <a:solidFill>
-                  <a:srgbClr val="666666"/>
-                </a:solidFill>
-                <a:latin typeface="Lato"/>
-              </a:rPr>
-              <a:t>9</a:t>
-            </a:r>
-          </a:p>
-        </p:txBody>
-      </p:sp>
-      <p:sp>
-        <p:nvSpPr>
-          <p:cNvPr id="6" name="TextBox 5"/>
-          <p:cNvSpPr txBox="1"/>
-          <p:nvPr/>
-        </p:nvSpPr>
-        <p:spPr>
-          <a:xfrm>
-            <a:off x="457200" y="1371600"/>
-            <a:ext cx="11247120" cy="4846320"/>
-          </a:xfrm>
-          <a:prstGeom prst="rect">
-            <a:avLst/>
-          </a:prstGeom>
-          <a:noFill/>
-        </p:spPr>
-        <p:txBody>
-          <a:bodyPr wrap="square">
-            <a:spAutoFit/>
-          </a:bodyPr>
-          <a:lstStyle/>
-          <a:p>
-            <a:pPr>
-              <a:spcAft>
-                <a:spcPts val="800"/>
-              </a:spcAft>
-            </a:pPr>
-            <a:r>
-              <a:rPr sz="1300" b="1">
-                <a:solidFill>
-                  <a:srgbClr val="1A1B26"/>
-                </a:solidFill>
-                <a:latin typeface="Lato"/>
-              </a:rPr>
-              <a:t>•  At the 34-SMA</a:t>
-            </a:r>
-            <a:r>
-              <a:rPr sz="1300">
-                <a:solidFill>
-                  <a:srgbClr val="1A1B26"/>
-                </a:solidFill>
-                <a:latin typeface="Lato"/>
-              </a:rPr>
-              <a:t> does the opening drive stall at the level or trade through it? A fill that comes with size lifting the offer (long) or hitting the bid (short) into the level is the good version; a fill inside a one-minute flush that keeps going is the stop.</a:t>
-            </a:r>
-          </a:p>
-          <a:p>
-            <a:pPr>
-              <a:spcAft>
-                <a:spcPts val="800"/>
-              </a:spcAft>
-            </a:pPr>
-            <a:r>
-              <a:rPr sz="1300" b="1">
-                <a:solidFill>
-                  <a:srgbClr val="1A1B26"/>
-                </a:solidFill>
-                <a:latin typeface="Lato"/>
-              </a:rPr>
-              <a:t>•  Premarket VWAP</a:t>
-            </a:r>
-            <a:r>
-              <a:rPr sz="1300">
-                <a:solidFill>
-                  <a:srgbClr val="1A1B26"/>
-                </a:solidFill>
-                <a:latin typeface="Lato"/>
-              </a:rPr>
-              <a:t> the second reference. For a long, price holding between the 34-SMA and the PM VWAP after the fill is confirmation; a print back below the PM VWAP with the 9-EMA turning is the early warning the 15-minute close will confirm.</a:t>
-            </a:r>
-          </a:p>
-          <a:p>
-            <a:pPr>
-              <a:spcAft>
-                <a:spcPts val="800"/>
-              </a:spcAft>
-            </a:pPr>
-            <a:r>
-              <a:rPr sz="1300" b="1">
-                <a:solidFill>
-                  <a:srgbClr val="1A1B26"/>
-                </a:solidFill>
-                <a:latin typeface="Lato"/>
-              </a:rPr>
-              <a:t>•  The 09:45 close</a:t>
-            </a:r>
-            <a:r>
-              <a:rPr sz="1300">
-                <a:solidFill>
-                  <a:srgbClr val="1A1B26"/>
-                </a:solidFill>
-                <a:latin typeface="Lato"/>
-              </a:rPr>
-              <a:t> the first completed bar. Above the 9-EMA arms the exit and says the drive is real; below it and the trade is living on the stop.</a:t>
-            </a:r>
-          </a:p>
-          <a:p>
-            <a:pPr>
-              <a:spcAft>
-                <a:spcPts val="800"/>
-              </a:spcAft>
-            </a:pPr>
-            <a:r>
-              <a:rPr sz="1300" b="1">
-                <a:solidFill>
-                  <a:srgbClr val="1A1B26"/>
-                </a:solidFill>
-                <a:latin typeface="Lato"/>
-              </a:rPr>
-              <a:t>•  Level to watch on the tape</a:t>
-            </a:r>
-            <a:r>
-              <a:rPr sz="1300">
-                <a:solidFill>
-                  <a:srgbClr val="1A1B26"/>
-                </a:solidFill>
-                <a:latin typeface="Lato"/>
-              </a:rPr>
-              <a:t> the fill price itself. The trade that never comes back to the fill after 09:45 is the runner; the one that keeps testing it is a scratch waiting to happen.</a:t>
-            </a:r>
-          </a:p>
-          <a:p>
-            <a:pPr>
-              <a:spcAft>
-                <a:spcPts val="800"/>
-              </a:spcAft>
-            </a:pPr>
-            <a:r>
-              <a:rPr sz="1300" b="1">
-                <a:solidFill>
-                  <a:srgbClr val="1A1B26"/>
-                </a:solidFill>
-                <a:latin typeface="Lato"/>
-              </a:rPr>
-              <a:t>•  Speed</a:t>
-            </a:r>
-            <a:r>
-              <a:rPr sz="1300">
-                <a:solidFill>
-                  <a:srgbClr val="1A1B26"/>
-                </a:solidFill>
-                <a:latin typeface="Lato"/>
-              </a:rPr>
-              <a:t> median one minute from fill to stop in the losing form. If the first minute after the fill runs against you, there is no decision to make; the stop makes it.</a:t>
             </a:r>
           </a:p>
         </p:txBody>

</xml_diff>